<commit_message>
Real Snapdragon X Elite NPU benchmarks via Qualcomm AI Hub; clean up repo (gitignore secrets, remove dev helper, doc metadata)
</commit_message>
<xml_diff>
--- a/submission/NotesNPU_Pitch.pptx
+++ b/submission/NotesNPU_Pitch.pptx
@@ -8071,7 +8071,7 @@
                 </a:solidFill>
                 <a:latin typeface="Segoe UI"/>
               </a:rPr>
-              <a:t>Whisper encoder = dense transformer over 1500 frames, a good fit for the Hexagon HTP's FP16 tensor engines (46 ms per 30 s of audio on X Elite, from AI Hub).</a:t>
+              <a:t>Whisper encoder = dense transformer over 1500 frames, a good fit for the Hexagon HTP's FP16 tensor engines (measured: 45.5 ms per 30 s of audio on X Elite).</a:t>
             </a:r>
           </a:p>
           <a:p>
@@ -8347,7 +8347,7 @@
                 </a:solidFill>
                 <a:latin typeface="Segoe UI"/>
               </a:rPr>
-              <a:t>Performance: NPU vs CPU</a:t>
+              <a:t>Performance: measured on a real Snapdragon NPU</a:t>
             </a:r>
           </a:p>
         </p:txBody>
@@ -8536,7 +8536,7 @@
                           </a:solidFill>
                           <a:latin typeface="Segoe UI"/>
                         </a:rPr>
-                        <a:t>5.7x real time</a:t>
+                        <a:t>5.7x real time (14.9 s)</a:t>
                       </a:r>
                     </a:p>
                   </a:txBody>
@@ -8604,7 +8604,7 @@
                           </a:solidFill>
                           <a:latin typeface="Segoe UI"/>
                         </a:rPr>
-                        <a:t>Snapdragon X Elite NPU (AI Hub reference)</a:t>
+                        <a:t>Snapdragon X Elite NPU (measured on Qualcomm AI Hub)</a:t>
                       </a:r>
                     </a:p>
                   </a:txBody>
@@ -8626,7 +8626,7 @@
                           </a:solidFill>
                           <a:latin typeface="Segoe UI"/>
                         </a:rPr>
-                        <a:t>~100x real time</a:t>
+                        <a:t>~80x real time (~1.1 s)</a:t>
                       </a:r>
                     </a:p>
                   </a:txBody>
@@ -8648,7 +8648,7 @@
                           </a:solidFill>
                           <a:latin typeface="Segoe UI"/>
                         </a:rPr>
-                        <a:t>46 ms</a:t>
+                        <a:t>45.5 ms</a:t>
                       </a:r>
                     </a:p>
                   </a:txBody>
@@ -8694,7 +8694,7 @@
                           </a:solidFill>
                           <a:latin typeface="Segoe UI"/>
                         </a:rPr>
-                        <a:t>Snapdragon HP PC NPU (my run)</a:t>
+                        <a:t>NPU speed-up</a:t>
                       </a:r>
                     </a:p>
                   </a:txBody>
@@ -8716,7 +8716,7 @@
                           </a:solidFill>
                           <a:latin typeface="Segoe UI"/>
                         </a:rPr>
-                        <a:t>run core.bench</a:t>
+                        <a:t>~14x end to end</a:t>
                       </a:r>
                     </a:p>
                   </a:txBody>
@@ -8738,7 +8738,7 @@
                           </a:solidFill>
                           <a:latin typeface="Segoe UI"/>
                         </a:rPr>
-                        <a:t>-</a:t>
+                        <a:t>28.8x</a:t>
                       </a:r>
                     </a:p>
                   </a:txBody>
@@ -8760,7 +8760,7 @@
                           </a:solidFill>
                           <a:latin typeface="Segoe UI"/>
                         </a:rPr>
-                        <a:t>-</a:t>
+                        <a:t>11.8x</a:t>
                       </a:r>
                     </a:p>
                   </a:txBody>
@@ -8783,8 +8783,8 @@
         </p:nvSpPr>
         <p:spPr>
           <a:xfrm>
-            <a:off x="548640" y="4206240"/>
-            <a:ext cx="11064240" cy="1737360"/>
+            <a:off x="548640" y="3931920"/>
+            <a:ext cx="11064240" cy="2286000"/>
           </a:xfrm>
           <a:prstGeom prst="rect">
             <a:avLst/>
@@ -8827,8 +8827,8 @@
         </p:nvSpPr>
         <p:spPr>
           <a:xfrm>
-            <a:off x="822960" y="4343400"/>
-            <a:ext cx="10607040" cy="1554480"/>
+            <a:off x="731520" y="4023360"/>
+            <a:ext cx="10698480" cy="2194560"/>
           </a:xfrm>
           <a:prstGeom prst="rect">
             <a:avLst/>
@@ -8841,39 +8841,103 @@
           </a:bodyPr>
           <a:lstStyle/>
           <a:p>
-            <a:pPr algn="l"/>
-            <a:r>
-              <a:rPr sz="1700" b="0">
+            <a:pPr>
+              <a:spcAft>
+                <a:spcPts val="400"/>
+              </a:spcAft>
+            </a:pPr>
+            <a:r>
+              <a:rPr sz="800">
+                <a:solidFill>
+                  <a:srgbClr val="E41E2B"/>
+                </a:solidFill>
+                <a:latin typeface="Segoe UI"/>
+              </a:rPr>
+              <a:t>■  </a:t>
+            </a:r>
+            <a:r>
+              <a:rPr sz="1400">
                 <a:solidFill>
                   <a:srgbClr val="14171F"/>
                 </a:solidFill>
                 <a:latin typeface="Segoe UI"/>
               </a:rPr>
-              <a:t>AI Hub reference: ~28x faster encoder and ~12x faster decoding on the NPU than my laptop-CPU baseline</a:t>
-            </a:r>
-          </a:p>
-          <a:p>
-            <a:pPr algn="l"/>
-            <a:r>
-              <a:rPr sz="1700" b="0">
+              <a:t>Measured on a real Snapdragon X Elite (Qualcomm AI Hub hosted device): encoder 45.5 ms per 30 s of audio, decoder 3.8 ms per token.</a:t>
+            </a:r>
+          </a:p>
+          <a:p>
+            <a:pPr>
+              <a:spcAft>
+                <a:spcPts val="400"/>
+              </a:spcAft>
+            </a:pPr>
+            <a:r>
+              <a:rPr sz="800">
+                <a:solidFill>
+                  <a:srgbClr val="E41E2B"/>
+                </a:solidFill>
+                <a:latin typeface="Segoe UI"/>
+              </a:rPr>
+              <a:t>■  </a:t>
+            </a:r>
+            <a:r>
+              <a:rPr sz="1400">
                 <a:solidFill>
                   <a:srgbClr val="14171F"/>
                 </a:solidFill>
                 <a:latin typeface="Segoe UI"/>
               </a:rPr>
-              <a:t>A 1-hour lecture transcribes in well under a minute, on battery, with the CPU left free.</a:t>
-            </a:r>
-          </a:p>
-          <a:p>
-            <a:pPr algn="l"/>
-            <a:r>
-              <a:rPr sz="1700" b="0">
+              <a:t>100% of ops on the NPU: 556 encoder ops + 975 decoder ops on the Hexagon HTP, none on the CPU; peak memory 34 MB / 60 MB.</a:t>
+            </a:r>
+          </a:p>
+          <a:p>
+            <a:pPr>
+              <a:spcAft>
+                <a:spcPts val="400"/>
+              </a:spcAft>
+            </a:pPr>
+            <a:r>
+              <a:rPr sz="800">
+                <a:solidFill>
+                  <a:srgbClr val="E41E2B"/>
+                </a:solidFill>
+                <a:latin typeface="Segoe UI"/>
+              </a:rPr>
+              <a:t>■  </a:t>
+            </a:r>
+            <a:r>
+              <a:rPr sz="1400">
                 <a:solidFill>
                   <a:srgbClr val="14171F"/>
                 </a:solidFill>
                 <a:latin typeface="Segoe UI"/>
               </a:rPr>
-              <a:t>Reproduce: python -m core.bench --llm   (built-in benchmark tab in the app)</a:t>
+              <a:t>Accuracy: NPU (FP16) encoder output matches the FP32 CPU reference with cosine similarity 0.999, and gives an identical, correct transcript of the sample lecture.</a:t>
+            </a:r>
+          </a:p>
+          <a:p>
+            <a:pPr>
+              <a:spcAft>
+                <a:spcPts val="400"/>
+              </a:spcAft>
+            </a:pPr>
+            <a:r>
+              <a:rPr sz="800">
+                <a:solidFill>
+                  <a:srgbClr val="E41E2B"/>
+                </a:solidFill>
+                <a:latin typeface="Segoe UI"/>
+              </a:rPr>
+              <a:t>■  </a:t>
+            </a:r>
+            <a:r>
+              <a:rPr sz="1400">
+                <a:solidFill>
+                  <a:srgbClr val="14171F"/>
+                </a:solidFill>
+                <a:latin typeface="Segoe UI"/>
+              </a:rPr>
+              <a:t>The 85 s sample lecture takes ~1.1 s on the NPU vs 14.9 s on a laptop CPU.</a:t>
             </a:r>
           </a:p>
         </p:txBody>

</xml_diff>

<commit_message>
Add author and GitHub link; rebuild pitch deck and description
</commit_message>
<xml_diff>
--- a/submission/NotesNPU_Pitch.pptx
+++ b/submission/NotesNPU_Pitch.pptx
@@ -3321,7 +3321,7 @@
                 </a:solidFill>
                 <a:latin typeface="Segoe UI"/>
               </a:rPr>
-              <a:t>Saira  |  Snapdragon AI Lab Build &amp; Present Challenge 2026</a:t>
+              <a:t>Mohammed Haris Suhaib M  |  Snapdragon AI Lab Build &amp; Present Challenge 2026</a:t>
             </a:r>
           </a:p>
           <a:p>
@@ -3333,7 +3333,7 @@
                 </a:solidFill>
                 <a:latin typeface="Segoe UI"/>
               </a:rPr>
-              <a:t>https://github.com/&lt;your-username&gt;/notesnpu</a:t>
+              <a:t>https://github.com/mdharishsuhaib/NotesNPU</a:t>
             </a:r>
           </a:p>
         </p:txBody>
@@ -3903,7 +3903,7 @@
                 </a:solidFill>
                 <a:latin typeface="Segoe UI"/>
               </a:rPr>
-              <a:t>https://github.com/&lt;your-username&gt;/notesnpu</a:t>
+              <a:t>https://github.com/mdharishsuhaib/NotesNPU</a:t>
             </a:r>
           </a:p>
           <a:p>
@@ -3915,7 +3915,7 @@
                 </a:solidFill>
                 <a:latin typeface="Segoe UI"/>
               </a:rPr>
-              <a:t>Saira</a:t>
+              <a:t>Mohammed Haris Suhaib M</a:t>
             </a:r>
           </a:p>
         </p:txBody>

</xml_diff>

<commit_message>
Add Snapdragon X Elite CPU vs NPU benchmark on the same device; remove dev-machine details from docs and screenshots
</commit_message>
<xml_diff>
--- a/submission/NotesNPU_Pitch.pptx
+++ b/submission/NotesNPU_Pitch.pptx
@@ -6095,7 +6095,7 @@
         <p:spPr>
           <a:xfrm>
             <a:off x="548640" y="1371600"/>
-            <a:ext cx="4361941" cy="4480560"/>
+            <a:ext cx="4629340" cy="4480560"/>
           </a:xfrm>
           <a:prstGeom prst="rect">
             <a:avLst/>
@@ -6118,8 +6118,8 @@
         </p:blipFill>
         <p:spPr>
           <a:xfrm>
-            <a:off x="5184901" y="1371600"/>
-            <a:ext cx="4361941" cy="4480560"/>
+            <a:off x="5452300" y="1371600"/>
+            <a:ext cx="4629340" cy="4480560"/>
           </a:xfrm>
           <a:prstGeom prst="rect">
             <a:avLst/>
@@ -8514,7 +8514,7 @@
                           </a:solidFill>
                           <a:latin typeface="Segoe UI"/>
                         </a:rPr>
-                        <a:t>Intel i5-7200U laptop (dev machine), CPU</a:t>
+                        <a:t>Snapdragon X Elite, Oryon CPU (measured on Qualcomm AI Hub)</a:t>
                       </a:r>
                     </a:p>
                   </a:txBody>
@@ -8536,7 +8536,7 @@
                           </a:solidFill>
                           <a:latin typeface="Segoe UI"/>
                         </a:rPr>
-                        <a:t>5.7x real time (14.9 s)</a:t>
+                        <a:t>~14x real time (~6.1 s)</a:t>
                       </a:r>
                     </a:p>
                   </a:txBody>
@@ -8558,7 +8558,7 @@
                           </a:solidFill>
                           <a:latin typeface="Segoe UI"/>
                         </a:rPr>
-                        <a:t>1312 ms</a:t>
+                        <a:t>1286 ms</a:t>
                       </a:r>
                     </a:p>
                   </a:txBody>
@@ -8580,7 +8580,7 @@
                           </a:solidFill>
                           <a:latin typeface="Segoe UI"/>
                         </a:rPr>
-                        <a:t>44.8 ms</a:t>
+                        <a:t>9.1 ms</a:t>
                       </a:r>
                     </a:p>
                   </a:txBody>
@@ -8604,7 +8604,7 @@
                           </a:solidFill>
                           <a:latin typeface="Segoe UI"/>
                         </a:rPr>
-                        <a:t>Snapdragon X Elite NPU (measured on Qualcomm AI Hub)</a:t>
+                        <a:t>Snapdragon X Elite, Hexagon NPU (measured on Qualcomm AI Hub)</a:t>
                       </a:r>
                     </a:p>
                   </a:txBody>
@@ -8716,7 +8716,7 @@
                           </a:solidFill>
                           <a:latin typeface="Segoe UI"/>
                         </a:rPr>
-                        <a:t>~14x end to end</a:t>
+                        <a:t>~5.7x end to end</a:t>
                       </a:r>
                     </a:p>
                   </a:txBody>
@@ -8738,7 +8738,7 @@
                           </a:solidFill>
                           <a:latin typeface="Segoe UI"/>
                         </a:rPr>
-                        <a:t>28.8x</a:t>
+                        <a:t>28.3x</a:t>
                       </a:r>
                     </a:p>
                   </a:txBody>
@@ -8760,7 +8760,7 @@
                           </a:solidFill>
                           <a:latin typeface="Segoe UI"/>
                         </a:rPr>
-                        <a:t>11.8x</a:t>
+                        <a:t>2.4x</a:t>
                       </a:r>
                     </a:p>
                   </a:txBody>
@@ -8937,7 +8937,7 @@
                 </a:solidFill>
                 <a:latin typeface="Segoe UI"/>
               </a:rPr>
-              <a:t>The 85 s sample lecture takes ~1.1 s on the NPU vs 14.9 s on a laptop CPU.</a:t>
+              <a:t>The 85 s sample lecture takes ~1.1 s on the NPU vs ~6.1 s on the same Snapdragon X Elite's Oryon CPU.</a:t>
             </a:r>
           </a:p>
         </p:txBody>

</xml_diff>